<commit_message>
vault backup: 2026-04-29 17:51:59
</commit_message>
<xml_diff>
--- a/030_Project/032_Proposed Project/09_개인기초 2차/그림2_연구로드맵.pptx
+++ b/030_Project/032_Proposed Project/09_개인기초 2차/그림2_연구로드맵.pptx
@@ -22694,8 +22694,8 @@
         </p:nvSpPr>
         <p:spPr>
           <a:xfrm>
-            <a:off x="3132000" y="691200"/>
-            <a:ext cx="2736000" cy="1907397"/>
+            <a:off x="3136233" y="640400"/>
+            <a:ext cx="2736000" cy="1951735"/>
           </a:xfrm>
           <a:prstGeom prst="rect">
             <a:avLst/>
@@ -22703,10 +22703,8 @@
           <a:solidFill>
             <a:srgbClr val="F3E5F5"/>
           </a:solidFill>
-          <a:ln w="6350">
-            <a:solidFill>
-              <a:srgbClr val="9C27B0"/>
-            </a:solidFill>
+          <a:ln>
+            <a:noFill/>
           </a:ln>
         </p:spPr>
         <p:style>
@@ -26673,6 +26671,103 @@
           </p:txBody>
         </p:sp>
       </p:grpSp>
+      <p:sp>
+        <p:nvSpPr>
+          <p:cNvPr id="139" name="Rectangle 138">
+            <a:extLst>
+              <a:ext uri="{FF2B5EF4-FFF2-40B4-BE49-F238E27FC236}">
+                <a16:creationId xmlns:a16="http://schemas.microsoft.com/office/drawing/2014/main" id="{3D54C0FF-E418-5003-58F2-1F9C4C66052C}"/>
+              </a:ext>
+            </a:extLst>
+          </p:cNvPr>
+          <p:cNvSpPr/>
+          <p:nvPr/>
+        </p:nvSpPr>
+        <p:spPr>
+          <a:xfrm>
+            <a:off x="9306000" y="3267934"/>
+            <a:ext cx="1368000" cy="927089"/>
+          </a:xfrm>
+          <a:prstGeom prst="rect">
+            <a:avLst/>
+          </a:prstGeom>
+          <a:solidFill>
+            <a:srgbClr val="F3E5F5"/>
+          </a:solidFill>
+          <a:ln w="6350">
+            <a:noFill/>
+          </a:ln>
+        </p:spPr>
+        <p:style>
+          <a:lnRef idx="1">
+            <a:schemeClr val="accent1"/>
+          </a:lnRef>
+          <a:fillRef idx="3">
+            <a:schemeClr val="accent1"/>
+          </a:fillRef>
+          <a:effectRef idx="2">
+            <a:schemeClr val="accent1"/>
+          </a:effectRef>
+          <a:fontRef idx="minor">
+            <a:schemeClr val="lt1"/>
+          </a:fontRef>
+        </p:style>
+        <p:txBody>
+          <a:bodyPr rtlCol="0" anchor="ctr"/>
+          <a:lstStyle/>
+          <a:p>
+            <a:pPr algn="ctr"/>
+            <a:endParaRPr/>
+          </a:p>
+        </p:txBody>
+      </p:sp>
+      <p:pic>
+        <p:nvPicPr>
+          <p:cNvPr id="140" name="Picture 4">
+            <a:extLst>
+              <a:ext uri="{FF2B5EF4-FFF2-40B4-BE49-F238E27FC236}">
+                <a16:creationId xmlns:a16="http://schemas.microsoft.com/office/drawing/2014/main" id="{A39F0CAF-9CC6-0696-239F-0070FC28467A}"/>
+              </a:ext>
+            </a:extLst>
+          </p:cNvPr>
+          <p:cNvPicPr>
+            <a:picLocks noChangeAspect="1" noChangeArrowheads="1"/>
+          </p:cNvPicPr>
+          <p:nvPr/>
+        </p:nvPicPr>
+        <p:blipFill>
+          <a:blip r:embed="rId9">
+            <a:extLst>
+              <a:ext uri="{28A0092B-C50C-407E-A947-70E740481C1C}">
+                <a14:useLocalDpi xmlns:a14="http://schemas.microsoft.com/office/drawing/2010/main" val="0"/>
+              </a:ext>
+            </a:extLst>
+          </a:blip>
+          <a:srcRect/>
+          <a:stretch>
+            <a:fillRect/>
+          </a:stretch>
+        </p:blipFill>
+        <p:spPr bwMode="auto">
+          <a:xfrm>
+            <a:off x="3419985" y="1002059"/>
+            <a:ext cx="2225723" cy="1452110"/>
+          </a:xfrm>
+          <a:prstGeom prst="rect">
+            <a:avLst/>
+          </a:prstGeom>
+          <a:noFill/>
+          <a:extLst>
+            <a:ext uri="{909E8E84-426E-40DD-AFC4-6F175D3DCCD1}">
+              <a14:hiddenFill xmlns:a14="http://schemas.microsoft.com/office/drawing/2010/main">
+                <a:solidFill>
+                  <a:srgbClr val="FFFFFF"/>
+                </a:solidFill>
+              </a14:hiddenFill>
+            </a:ext>
+          </a:extLst>
+        </p:spPr>
+      </p:pic>
     </p:spTree>
     <p:extLst>
       <p:ext uri="{BB962C8B-B14F-4D97-AF65-F5344CB8AC3E}">
@@ -26732,8 +26827,102 @@
         </p:blipFill>
         <p:spPr bwMode="auto">
           <a:xfrm>
-            <a:off x="2660693" y="1210734"/>
+            <a:off x="1005459" y="1096434"/>
             <a:ext cx="2793087" cy="2747433"/>
+          </a:xfrm>
+          <a:prstGeom prst="rect">
+            <a:avLst/>
+          </a:prstGeom>
+          <a:noFill/>
+          <a:extLst>
+            <a:ext uri="{909E8E84-426E-40DD-AFC4-6F175D3DCCD1}">
+              <a14:hiddenFill xmlns:a14="http://schemas.microsoft.com/office/drawing/2010/main">
+                <a:solidFill>
+                  <a:srgbClr val="FFFFFF"/>
+                </a:solidFill>
+              </a14:hiddenFill>
+            </a:ext>
+          </a:extLst>
+        </p:spPr>
+      </p:pic>
+      <p:pic>
+        <p:nvPicPr>
+          <p:cNvPr id="1028" name="Picture 4">
+            <a:extLst>
+              <a:ext uri="{FF2B5EF4-FFF2-40B4-BE49-F238E27FC236}">
+                <a16:creationId xmlns:a16="http://schemas.microsoft.com/office/drawing/2014/main" id="{4DBC0590-1363-0719-BF9E-FA07FF056E7C}"/>
+              </a:ext>
+            </a:extLst>
+          </p:cNvPr>
+          <p:cNvPicPr>
+            <a:picLocks noChangeAspect="1" noChangeArrowheads="1"/>
+          </p:cNvPicPr>
+          <p:nvPr/>
+        </p:nvPicPr>
+        <p:blipFill>
+          <a:blip r:embed="rId3">
+            <a:extLst>
+              <a:ext uri="{28A0092B-C50C-407E-A947-70E740481C1C}">
+                <a14:useLocalDpi xmlns:a14="http://schemas.microsoft.com/office/drawing/2010/main" val="0"/>
+              </a:ext>
+            </a:extLst>
+          </a:blip>
+          <a:srcRect/>
+          <a:stretch>
+            <a:fillRect/>
+          </a:stretch>
+        </p:blipFill>
+        <p:spPr bwMode="auto">
+          <a:xfrm>
+            <a:off x="4906432" y="2375217"/>
+            <a:ext cx="2251075" cy="1468650"/>
+          </a:xfrm>
+          <a:prstGeom prst="rect">
+            <a:avLst/>
+          </a:prstGeom>
+          <a:noFill/>
+          <a:extLst>
+            <a:ext uri="{909E8E84-426E-40DD-AFC4-6F175D3DCCD1}">
+              <a14:hiddenFill xmlns:a14="http://schemas.microsoft.com/office/drawing/2010/main">
+                <a:solidFill>
+                  <a:srgbClr val="FFFFFF"/>
+                </a:solidFill>
+              </a14:hiddenFill>
+            </a:ext>
+          </a:extLst>
+        </p:spPr>
+      </p:pic>
+      <p:pic>
+        <p:nvPicPr>
+          <p:cNvPr id="1030" name="Picture 6">
+            <a:extLst>
+              <a:ext uri="{FF2B5EF4-FFF2-40B4-BE49-F238E27FC236}">
+                <a16:creationId xmlns:a16="http://schemas.microsoft.com/office/drawing/2014/main" id="{712660C8-4D5C-CE20-4AF9-2FD07011A2B6}"/>
+              </a:ext>
+            </a:extLst>
+          </p:cNvPr>
+          <p:cNvPicPr>
+            <a:picLocks noChangeAspect="1" noChangeArrowheads="1"/>
+          </p:cNvPicPr>
+          <p:nvPr/>
+        </p:nvPicPr>
+        <p:blipFill>
+          <a:blip r:embed="rId4">
+            <a:extLst>
+              <a:ext uri="{28A0092B-C50C-407E-A947-70E740481C1C}">
+                <a14:useLocalDpi xmlns:a14="http://schemas.microsoft.com/office/drawing/2010/main" val="0"/>
+              </a:ext>
+            </a:extLst>
+          </a:blip>
+          <a:srcRect/>
+          <a:stretch>
+            <a:fillRect/>
+          </a:stretch>
+        </p:blipFill>
+        <p:spPr bwMode="auto">
+          <a:xfrm>
+            <a:off x="5349344" y="4015904"/>
+            <a:ext cx="1232431" cy="457133"/>
           </a:xfrm>
           <a:prstGeom prst="rect">
             <a:avLst/>

</xml_diff>